<commit_message>
Model update (new pricing), outreach tracker, vertical scrub (#62)
Updates the financial model + pitch deck for the $2,500 setup + $1,500/mo +
$25k buyout pricing (setup fees in revenue/EBITDA/cash, ARR recurring-only, new
LTV/CAC/payback metrics), adds marketing/outreach-tracker.xlsx, and scrubs
plumber/HVAC/contractor/missed-call references from the marketing/sales copy.
Frozen product code and the missedcallproject.com proof URL left intact.
</commit_message>
<xml_diff>
--- a/finance/antigravity_pitch_deck.pptx
+++ b/finance/antigravity_pitch_deck.pptx
@@ -198,13 +198,13 @@
                 <c:formatCode>General</c:formatCode>
                 <c:ptCount val="3"/>
                 <c:pt idx="0">
-                  <c:v>202</c:v>
+                  <c:v>262</c:v>
                 </c:pt>
                 <c:pt idx="1">
-                  <c:v>674</c:v>
+                  <c:v>794</c:v>
                 </c:pt>
                 <c:pt idx="2">
-                  <c:v>1313</c:v>
+                  <c:v>1493</c:v>
                 </c:pt>
               </c:numCache>
             </c:numRef>
@@ -281,13 +281,13 @@
                 <c:formatCode>General</c:formatCode>
                 <c:ptCount val="3"/>
                 <c:pt idx="0">
-                  <c:v>78</c:v>
+                  <c:v>136</c:v>
                 </c:pt>
                 <c:pt idx="1">
-                  <c:v>510</c:v>
+                  <c:v>626</c:v>
                 </c:pt>
                 <c:pt idx="2">
-                  <c:v>1097</c:v>
+                  <c:v>1271</c:v>
                 </c:pt>
               </c:numCache>
             </c:numRef>
@@ -1282,7 +1282,7 @@
           <a:p>
             <a:r>
               <a:rPr lang="en-US" dirty="0"/>
-              <a:t>Revenue 202k/674k/1.31M; EBITDA 78k/510k/1.10M; ending ARR 347k/909k/1.6M. Profitable Y1 after a real founder salary.</a:t>
+              <a:t>Revenue (incl. $2,500 setup fees) 262k/794k/1.49M; EBITDA 136k/626k/1.27M; ending recurring ARR 347k/909k/1.6M. EBITDA-positive by month 2 after a real founder salary.</a:t>
             </a:r>
             <a:endParaRPr lang="en-US" dirty="0"/>
           </a:p>
@@ -5910,8 +5910,8 @@
         </p:nvSpPr>
         <p:spPr>
           <a:xfrm>
-            <a:off x="8046720" y="5532120"/>
-            <a:ext cx="3246120" cy="640080"/>
+            <a:off x="8046720" y="5440680"/>
+            <a:ext cx="3246120" cy="777240"/>
           </a:xfrm>
           <a:prstGeom prst="rect">
             <a:avLst/>
@@ -5925,12 +5925,12 @@
           <a:p>
             <a:pPr indent="0" marL="0">
               <a:lnSpc>
-                <a:spcPts val="1500"/>
+                <a:spcPts val="1400"/>
               </a:lnSpc>
               <a:buNone/>
             </a:pPr>
             <a:r>
-              <a:rPr lang="en-US" sz="1150" i="1" dirty="0">
+              <a:rPr lang="en-US" sz="1100" i="1" dirty="0">
                 <a:solidFill>
                   <a:srgbClr val="CADCFC"/>
                 </a:solidFill>
@@ -5938,9 +5938,9 @@
                 <a:ea typeface="Calibri" pitchFamily="34" charset="-122"/>
                 <a:cs typeface="Calibri" pitchFamily="34" charset="-120"/>
               </a:rPr>
-              <a:t>Ending cash Year 3: $1.69M · EBITDA-positive from Year 1 (after an $8K/mo founder draw).</a:t>
-            </a:r>
-            <a:endParaRPr lang="en-US" sz="1150" dirty="0"/>
+              <a:t>Ending cash Year 3: $2.04M · EBITDA-positive by month 2 (after an $8K/mo founder draw). Revenue includes one-time setup fees; ARR is recurring-only.</a:t>
+            </a:r>
+            <a:endParaRPr lang="en-US" sz="1100" dirty="0"/>
           </a:p>
         </p:txBody>
       </p:sp>

</xml_diff>